<commit_message>
Review fixes before merge: no team seed that is also an everyday phrase
A category node matches any text holding all its words and
stories.resolve_category prefers the deepest, so seeding "carolina
hurricanes" filed a hurricane question - or a composed weather story -
under hockey. Teams whose names are also weather, nature, a place or the
news are left to grow (category_seed.LEFT_TO_GROW), "packers" and
"ravens" take their full names, and a test asks fourteen everyday
questions that must catch no team.

Also: the docs generator removes its temporary category tree, drops an
unused import, and its words follow the seed.

Co-Authored-By: Claude Opus 5.5 <noreply@anthropic.com>
Claude-Session: https://claude.ai/code/session_012h8xMG55fwQwhHen41hh6n
</commit_message>
<xml_diff>
--- a/docs/algorithm/FAM_Algorithm.pptx
+++ b/docs/algorithm/FAM_Algorithm.pptx
@@ -3805,7 +3805,7 @@
                 </a:solidFill>
                 <a:latin typeface="Calibri"/>
               </a:rPr>
-              <a:t>•  The NFL, NBA, MLB and NHL teams are seeded into the category tree under their leagues, so one fan's team is a subject from their first search.</a:t>
+              <a:t>•  Most NFL, NBA, MLB and NHL teams are seeded into the category tree under their leagues, so one fan's team is a subject from their first search. A team whose name is also weather or the news ('Carolina Hurricanes') is left to grow from real sports questions.</a:t>
             </a:r>
           </a:p>
         </p:txBody>
@@ -3844,7 +3844,7 @@
                 </a:solidFill>
                 <a:latin typeface="Calibri"/>
               </a:rPr>
-              <a:t>§202 in PROBLEMS.md  ·  fingerprint b2961ad9b5524ee7</a:t>
+              <a:t>§202 in PROBLEMS.md  ·  fingerprint 8ff02e6b227dbdaa</a:t>
             </a:r>
           </a:p>
         </p:txBody>
@@ -7152,7 +7152,7 @@
                 </a:solidFill>
                 <a:latin typeface="Calibri"/>
               </a:rPr>
-              <a:t>•  Every NFL, NBA, MLB and NHL team is seeded under its league</a:t>
+              <a:t>•  Most NFL, NBA, MLB and NHL teams are seeded under their league</a:t>
             </a:r>
           </a:p>
         </p:txBody>

</xml_diff>